<commit_message>
1000 Farms LinkedIn image (Fri 2 Oct): straight card, clean two-line source, caption file; never fall back to the soil cross-section cutout
Co-Authored-By: Claude Opus 5.5 <noreply@anthropic.com>
Claude-Session: https://claude.ai/code/session_014HGzAbxBh54nuyJHG7tse8
</commit_message>
<xml_diff>
--- a/templates/posts/october/02-10-2026-fri-li-1000-farms-study.pptx
+++ b/templates/posts/october/02-10-2026-fri-li-1000-farms-study.pptx
@@ -502,7 +502,7 @@
           <a:lstStyle/>
           <a:p>
             <a:r>
-              <a:t>LinkedIn image. Sources: Lundgren et al., Environmental Research: Food Systems, 2026, https://doi.org/10.1088/2976-601X/ae8f4e; Ecdysis Foundation press release, 17 September 2026, https://www.globenewswire.com/news-release/2026/09/17/3363925/0/en/regenerative-farming-outpaces-tech-based-carbon-capture-solutions-in-first-large-scale-systemic-study.html Right half: the slide 1 field collage on a taped paper card, on Food Web Green.</a:t>
+              <a:t>LinkedIn image. Sources: Lundgren et al., Environmental Research: Food Systems, 2026, https://doi.org/10.1088/2976-601X/ae8f4e; Ecdysis Foundation press release, 17 September 2026, https://www.globenewswire.com/news-release/2026/09/17/3363925/0/en/regenerative-farming-outpaces-tech-based-carbon-capture-solutions-in-first-large-scale-systemic-study.html Right half: the slide 1 field collage on a taped paper card (not tilted), on Food Web Green.</a:t>
             </a:r>
           </a:p>
         </p:txBody>
@@ -3567,9 +3567,9 @@
           <p:nvPr/>
         </p:nvSpPr>
         <p:spPr>
-          <a:xfrm rot="120000">
-            <a:off x="6096000" y="381000"/>
-            <a:ext cx="4953000" cy="4286250"/>
+          <a:xfrm>
+            <a:off x="6191250" y="571500"/>
+            <a:ext cx="4762500" cy="4095750"/>
           </a:xfrm>
           <a:prstGeom prst="rect">
             <a:avLst/>
@@ -3618,7 +3618,7 @@
         </p:nvSpPr>
         <p:spPr>
           <a:xfrm rot="19920000">
-            <a:off x="5953125" y="228600"/>
+            <a:off x="6048375" y="419100"/>
             <a:ext cx="1428750" cy="419100"/>
           </a:xfrm>
           <a:prstGeom prst="rect">
@@ -3664,7 +3664,7 @@
         </p:nvSpPr>
         <p:spPr>
           <a:xfrm rot="1680000">
-            <a:off x="9763125" y="228600"/>
+            <a:off x="9667875" y="419100"/>
             <a:ext cx="1428750" cy="419100"/>
           </a:xfrm>
           <a:prstGeom prst="rect">
@@ -3718,7 +3718,7 @@
         </p:blipFill>
         <p:spPr>
           <a:xfrm>
-            <a:off x="6557010" y="2152650"/>
+            <a:off x="6557010" y="2247900"/>
             <a:ext cx="4030980" cy="2080260"/>
           </a:xfrm>
           <a:prstGeom prst="rect">
@@ -3742,7 +3742,7 @@
         </p:blipFill>
         <p:spPr>
           <a:xfrm rot="21120000">
-            <a:off x="6688455" y="1224011"/>
+            <a:off x="6688455" y="1319261"/>
             <a:ext cx="2190750" cy="1114326"/>
           </a:xfrm>
           <a:prstGeom prst="rect">
@@ -3766,7 +3766,7 @@
         </p:blipFill>
         <p:spPr>
           <a:xfrm rot="11400000">
-            <a:off x="8462962" y="1277331"/>
+            <a:off x="8462962" y="1372581"/>
             <a:ext cx="1971675" cy="1007687"/>
           </a:xfrm>
           <a:prstGeom prst="rect">
@@ -3790,7 +3790,7 @@
         </p:blipFill>
         <p:spPr>
           <a:xfrm rot="5400000">
-            <a:off x="7367587" y="1906605"/>
+            <a:off x="7367587" y="2001855"/>
             <a:ext cx="2409825" cy="2572348"/>
           </a:xfrm>
           <a:prstGeom prst="rect">
@@ -3807,9 +3807,9 @@
         <p:grpSpPr>
           <a:xfrm rot="21240000">
             <a:off x="0" y="0"/>
-            <a:ext cx="7096125" cy="5543550"/>
+            <a:ext cx="7096125" cy="5638800"/>
             <a:chOff x="0" y="0"/>
-            <a:chExt cx="7096125" cy="5543550"/>
+            <a:chExt cx="7096125" cy="5638800"/>
           </a:xfrm>
         </p:grpSpPr>
         <p:sp>
@@ -3820,7 +3820,7 @@
           </p:nvSpPr>
           <p:spPr>
             <a:xfrm>
-              <a:off x="6534150" y="4684395"/>
+              <a:off x="6534150" y="4779645"/>
               <a:ext cx="76200" cy="649605"/>
             </a:xfrm>
             <a:prstGeom prst="rect">
@@ -3864,7 +3864,7 @@
           </p:nvSpPr>
           <p:spPr>
             <a:xfrm rot="8700000">
-              <a:off x="6153150" y="4537710"/>
+              <a:off x="6153150" y="4632960"/>
               <a:ext cx="419100" cy="209550"/>
             </a:xfrm>
             <a:prstGeom prst="ellipse">
@@ -3910,7 +3910,7 @@
           </p:nvSpPr>
           <p:spPr>
             <a:xfrm rot="2100000">
-              <a:off x="6572250" y="4537710"/>
+              <a:off x="6572250" y="4632960"/>
               <a:ext cx="419100" cy="209550"/>
             </a:xfrm>
             <a:prstGeom prst="ellipse">
@@ -3956,7 +3956,7 @@
           </p:nvSpPr>
           <p:spPr>
             <a:xfrm>
-              <a:off x="6048375" y="5229225"/>
+              <a:off x="6048375" y="5324475"/>
               <a:ext cx="1047750" cy="314325"/>
             </a:xfrm>
             <a:prstGeom prst="ellipse">
@@ -4008,7 +4008,7 @@
           </p:nvSpPr>
           <p:spPr>
             <a:xfrm>
-              <a:off x="6493668" y="5351328"/>
+              <a:off x="6493668" y="5446578"/>
               <a:ext cx="28208" cy="28208"/>
             </a:xfrm>
             <a:prstGeom prst="ellipse">
@@ -4052,7 +4052,7 @@
           </p:nvSpPr>
           <p:spPr>
             <a:xfrm>
-              <a:off x="6622622" y="5351328"/>
+              <a:off x="6622622" y="5446578"/>
               <a:ext cx="28208" cy="28208"/>
             </a:xfrm>
             <a:prstGeom prst="ellipse">
@@ -4096,7 +4096,7 @@
           </p:nvSpPr>
           <p:spPr>
             <a:xfrm rot="10800000">
-              <a:off x="6527922" y="5373492"/>
+              <a:off x="6527922" y="5468742"/>
               <a:ext cx="88655" cy="64476"/>
             </a:xfrm>
             <a:prstGeom prst="blockArc">
@@ -4137,612 +4137,15 @@
           </p:txBody>
         </p:sp>
       </p:grpSp>
-      <p:grpSp>
-        <p:nvGrpSpPr>
-          <p:cNvPr id="18" name="Group 17"/>
-          <p:cNvGrpSpPr/>
-          <p:nvPr/>
-        </p:nvGrpSpPr>
-        <p:grpSpPr>
-          <a:xfrm rot="1500000">
-            <a:off x="0" y="0"/>
-            <a:ext cx="10593705" cy="4743449"/>
-            <a:chOff x="0" y="0"/>
-            <a:chExt cx="10593705" cy="4743449"/>
-          </a:xfrm>
-        </p:grpSpPr>
-        <p:sp>
-          <p:nvSpPr>
-            <p:cNvPr id="19" name="Rectangle 18"/>
-            <p:cNvSpPr/>
-            <p:nvPr/>
-          </p:nvSpPr>
-          <p:spPr>
-            <a:xfrm rot="1500000">
-              <a:off x="9984667" y="4317960"/>
-              <a:ext cx="120015" cy="38100"/>
-            </a:xfrm>
-            <a:prstGeom prst="rect">
-              <a:avLst/>
-            </a:prstGeom>
-            <a:solidFill>
-              <a:srgbClr val="22371F"/>
-            </a:solidFill>
-            <a:ln>
-              <a:noFill/>
-            </a:ln>
-            <a:effectLst/>
-          </p:spPr>
-          <p:style>
-            <a:lnRef idx="1">
-              <a:schemeClr val="accent1"/>
-            </a:lnRef>
-            <a:fillRef idx="3">
-              <a:schemeClr val="accent1"/>
-            </a:fillRef>
-            <a:effectRef idx="2">
-              <a:schemeClr val="accent1"/>
-            </a:effectRef>
-            <a:fontRef idx="minor">
-              <a:schemeClr val="lt1"/>
-            </a:fontRef>
-          </p:style>
-          <p:txBody>
-            <a:bodyPr rtlCol="0" anchor="ctr"/>
-            <a:lstStyle/>
-            <a:p>
-              <a:pPr algn="ctr"/>
-            </a:p>
-          </p:txBody>
-        </p:sp>
-        <p:sp>
-          <p:nvSpPr>
-            <p:cNvPr id="20" name="Rectangle 19"/>
-            <p:cNvSpPr/>
-            <p:nvPr/>
-          </p:nvSpPr>
-          <p:spPr>
-            <a:xfrm>
-              <a:off x="9980295" y="4457700"/>
-              <a:ext cx="120015" cy="38100"/>
-            </a:xfrm>
-            <a:prstGeom prst="rect">
-              <a:avLst/>
-            </a:prstGeom>
-            <a:solidFill>
-              <a:srgbClr val="22371F"/>
-            </a:solidFill>
-            <a:ln>
-              <a:noFill/>
-            </a:ln>
-            <a:effectLst/>
-          </p:spPr>
-          <p:style>
-            <a:lnRef idx="1">
-              <a:schemeClr val="accent1"/>
-            </a:lnRef>
-            <a:fillRef idx="3">
-              <a:schemeClr val="accent1"/>
-            </a:fillRef>
-            <a:effectRef idx="2">
-              <a:schemeClr val="accent1"/>
-            </a:effectRef>
-            <a:fontRef idx="minor">
-              <a:schemeClr val="lt1"/>
-            </a:fontRef>
-          </p:style>
-          <p:txBody>
-            <a:bodyPr rtlCol="0" anchor="ctr"/>
-            <a:lstStyle/>
-            <a:p>
-              <a:pPr algn="ctr"/>
-            </a:p>
-          </p:txBody>
-        </p:sp>
-        <p:sp>
-          <p:nvSpPr>
-            <p:cNvPr id="21" name="Rectangle 20"/>
-            <p:cNvSpPr/>
-            <p:nvPr/>
-          </p:nvSpPr>
-          <p:spPr>
-            <a:xfrm rot="20100000">
-              <a:off x="9984667" y="4597439"/>
-              <a:ext cx="120015" cy="38100"/>
-            </a:xfrm>
-            <a:prstGeom prst="rect">
-              <a:avLst/>
-            </a:prstGeom>
-            <a:solidFill>
-              <a:srgbClr val="22371F"/>
-            </a:solidFill>
-            <a:ln>
-              <a:noFill/>
-            </a:ln>
-            <a:effectLst/>
-          </p:spPr>
-          <p:style>
-            <a:lnRef idx="1">
-              <a:schemeClr val="accent1"/>
-            </a:lnRef>
-            <a:fillRef idx="3">
-              <a:schemeClr val="accent1"/>
-            </a:fillRef>
-            <a:effectRef idx="2">
-              <a:schemeClr val="accent1"/>
-            </a:effectRef>
-            <a:fontRef idx="minor">
-              <a:schemeClr val="lt1"/>
-            </a:fontRef>
-          </p:style>
-          <p:txBody>
-            <a:bodyPr rtlCol="0" anchor="ctr"/>
-            <a:lstStyle/>
-            <a:p>
-              <a:pPr algn="ctr"/>
-            </a:p>
-          </p:txBody>
-        </p:sp>
-        <p:sp>
-          <p:nvSpPr>
-            <p:cNvPr id="22" name="Rectangle 21"/>
-            <p:cNvSpPr/>
-            <p:nvPr/>
-          </p:nvSpPr>
-          <p:spPr>
-            <a:xfrm rot="20100000">
-              <a:off x="10469317" y="4317960"/>
-              <a:ext cx="120015" cy="38100"/>
-            </a:xfrm>
-            <a:prstGeom prst="rect">
-              <a:avLst/>
-            </a:prstGeom>
-            <a:solidFill>
-              <a:srgbClr val="22371F"/>
-            </a:solidFill>
-            <a:ln>
-              <a:noFill/>
-            </a:ln>
-            <a:effectLst/>
-          </p:spPr>
-          <p:style>
-            <a:lnRef idx="1">
-              <a:schemeClr val="accent1"/>
-            </a:lnRef>
-            <a:fillRef idx="3">
-              <a:schemeClr val="accent1"/>
-            </a:fillRef>
-            <a:effectRef idx="2">
-              <a:schemeClr val="accent1"/>
-            </a:effectRef>
-            <a:fontRef idx="minor">
-              <a:schemeClr val="lt1"/>
-            </a:fontRef>
-          </p:style>
-          <p:txBody>
-            <a:bodyPr rtlCol="0" anchor="ctr"/>
-            <a:lstStyle/>
-            <a:p>
-              <a:pPr algn="ctr"/>
-            </a:p>
-          </p:txBody>
-        </p:sp>
-        <p:sp>
-          <p:nvSpPr>
-            <p:cNvPr id="23" name="Rectangle 22"/>
-            <p:cNvSpPr/>
-            <p:nvPr/>
-          </p:nvSpPr>
-          <p:spPr>
-            <a:xfrm>
-              <a:off x="10473690" y="4457700"/>
-              <a:ext cx="120015" cy="38100"/>
-            </a:xfrm>
-            <a:prstGeom prst="rect">
-              <a:avLst/>
-            </a:prstGeom>
-            <a:solidFill>
-              <a:srgbClr val="22371F"/>
-            </a:solidFill>
-            <a:ln>
-              <a:noFill/>
-            </a:ln>
-            <a:effectLst/>
-          </p:spPr>
-          <p:style>
-            <a:lnRef idx="1">
-              <a:schemeClr val="accent1"/>
-            </a:lnRef>
-            <a:fillRef idx="3">
-              <a:schemeClr val="accent1"/>
-            </a:fillRef>
-            <a:effectRef idx="2">
-              <a:schemeClr val="accent1"/>
-            </a:effectRef>
-            <a:fontRef idx="minor">
-              <a:schemeClr val="lt1"/>
-            </a:fontRef>
-          </p:style>
-          <p:txBody>
-            <a:bodyPr rtlCol="0" anchor="ctr"/>
-            <a:lstStyle/>
-            <a:p>
-              <a:pPr algn="ctr"/>
-            </a:p>
-          </p:txBody>
-        </p:sp>
-        <p:sp>
-          <p:nvSpPr>
-            <p:cNvPr id="24" name="Rectangle 23"/>
-            <p:cNvSpPr/>
-            <p:nvPr/>
-          </p:nvSpPr>
-          <p:spPr>
-            <a:xfrm rot="1500000">
-              <a:off x="10469317" y="4597439"/>
-              <a:ext cx="120015" cy="38100"/>
-            </a:xfrm>
-            <a:prstGeom prst="rect">
-              <a:avLst/>
-            </a:prstGeom>
-            <a:solidFill>
-              <a:srgbClr val="22371F"/>
-            </a:solidFill>
-            <a:ln>
-              <a:noFill/>
-            </a:ln>
-            <a:effectLst/>
-          </p:spPr>
-          <p:style>
-            <a:lnRef idx="1">
-              <a:schemeClr val="accent1"/>
-            </a:lnRef>
-            <a:fillRef idx="3">
-              <a:schemeClr val="accent1"/>
-            </a:fillRef>
-            <a:effectRef idx="2">
-              <a:schemeClr val="accent1"/>
-            </a:effectRef>
-            <a:fontRef idx="minor">
-              <a:schemeClr val="lt1"/>
-            </a:fontRef>
-          </p:style>
-          <p:txBody>
-            <a:bodyPr rtlCol="0" anchor="ctr"/>
-            <a:lstStyle/>
-            <a:p>
-              <a:pPr algn="ctr"/>
-            </a:p>
-          </p:txBody>
-        </p:sp>
-        <p:sp>
-          <p:nvSpPr>
-            <p:cNvPr id="25" name="Oval 24"/>
-            <p:cNvSpPr/>
-            <p:nvPr/>
-          </p:nvSpPr>
-          <p:spPr>
-            <a:xfrm>
-              <a:off x="10193655" y="4063365"/>
-              <a:ext cx="186690" cy="160020"/>
-            </a:xfrm>
-            <a:prstGeom prst="ellipse">
-              <a:avLst/>
-            </a:prstGeom>
-            <a:solidFill>
-              <a:srgbClr val="22371F"/>
-            </a:solidFill>
-            <a:ln w="57150">
-              <a:solidFill>
-                <a:srgbClr val="FFFFFF"/>
-              </a:solidFill>
-            </a:ln>
-            <a:effectLst/>
-          </p:spPr>
-          <p:style>
-            <a:lnRef idx="1">
-              <a:schemeClr val="accent1"/>
-            </a:lnRef>
-            <a:fillRef idx="3">
-              <a:schemeClr val="accent1"/>
-            </a:fillRef>
-            <a:effectRef idx="2">
-              <a:schemeClr val="accent1"/>
-            </a:effectRef>
-            <a:fontRef idx="minor">
-              <a:schemeClr val="lt1"/>
-            </a:fontRef>
-          </p:style>
-          <p:txBody>
-            <a:bodyPr rtlCol="0" anchor="ctr"/>
-            <a:lstStyle/>
-            <a:p>
-              <a:pPr algn="ctr"/>
-            </a:p>
-          </p:txBody>
-        </p:sp>
-        <p:sp>
-          <p:nvSpPr>
-            <p:cNvPr id="26" name="Oval 25"/>
-            <p:cNvSpPr/>
-            <p:nvPr/>
-          </p:nvSpPr>
-          <p:spPr>
-            <a:xfrm>
-              <a:off x="10086975" y="4176712"/>
-              <a:ext cx="400050" cy="566737"/>
-            </a:xfrm>
-            <a:prstGeom prst="ellipse">
-              <a:avLst/>
-            </a:prstGeom>
-            <a:solidFill>
-              <a:srgbClr val="2F4A3A"/>
-            </a:solidFill>
-            <a:ln w="57150">
-              <a:solidFill>
-                <a:srgbClr val="FFFFFF"/>
-              </a:solidFill>
-            </a:ln>
-            <a:effectLst>
-              <a:outerShdw blurRad="228600" dist="76200" dir="5400000" algn="t" rotWithShape="0">
-                <a:srgbClr val="000000">
-                  <a:alpha val="30000"/>
-                </a:srgbClr>
-              </a:outerShdw>
-            </a:effectLst>
-          </p:spPr>
-          <p:style>
-            <a:lnRef idx="1">
-              <a:schemeClr val="accent1"/>
-            </a:lnRef>
-            <a:fillRef idx="3">
-              <a:schemeClr val="accent1"/>
-            </a:fillRef>
-            <a:effectRef idx="2">
-              <a:schemeClr val="accent1"/>
-            </a:effectRef>
-            <a:fontRef idx="minor">
-              <a:schemeClr val="lt1"/>
-            </a:fontRef>
-          </p:style>
-          <p:txBody>
-            <a:bodyPr rtlCol="0" anchor="ctr"/>
-            <a:lstStyle/>
-            <a:p>
-              <a:pPr algn="ctr"/>
-            </a:p>
-          </p:txBody>
-        </p:sp>
-        <p:sp>
-          <p:nvSpPr>
-            <p:cNvPr id="27" name="Rectangle 26"/>
-            <p:cNvSpPr/>
-            <p:nvPr/>
-          </p:nvSpPr>
-          <p:spPr>
-            <a:xfrm>
-              <a:off x="10267950" y="4196715"/>
-              <a:ext cx="38100" cy="533400"/>
-            </a:xfrm>
-            <a:prstGeom prst="rect">
-              <a:avLst/>
-            </a:prstGeom>
-            <a:solidFill>
-              <a:srgbClr val="FFFFFF"/>
-            </a:solidFill>
-            <a:ln>
-              <a:noFill/>
-            </a:ln>
-            <a:effectLst/>
-          </p:spPr>
-          <p:style>
-            <a:lnRef idx="1">
-              <a:schemeClr val="accent1"/>
-            </a:lnRef>
-            <a:fillRef idx="3">
-              <a:schemeClr val="accent1"/>
-            </a:fillRef>
-            <a:effectRef idx="2">
-              <a:schemeClr val="accent1"/>
-            </a:effectRef>
-            <a:fontRef idx="minor">
-              <a:schemeClr val="lt1"/>
-            </a:fontRef>
-          </p:style>
-          <p:txBody>
-            <a:bodyPr rtlCol="0" anchor="ctr"/>
-            <a:lstStyle/>
-            <a:p>
-              <a:pPr algn="ctr"/>
-            </a:p>
-          </p:txBody>
-        </p:sp>
-        <p:sp>
-          <p:nvSpPr>
-            <p:cNvPr id="28" name="Oval 27"/>
-            <p:cNvSpPr/>
-            <p:nvPr/>
-          </p:nvSpPr>
-          <p:spPr>
-            <a:xfrm>
-              <a:off x="10166985" y="4350067"/>
-              <a:ext cx="53340" cy="53340"/>
-            </a:xfrm>
-            <a:prstGeom prst="ellipse">
-              <a:avLst/>
-            </a:prstGeom>
-            <a:solidFill>
-              <a:srgbClr val="DBE6A7"/>
-            </a:solidFill>
-            <a:ln>
-              <a:noFill/>
-            </a:ln>
-            <a:effectLst/>
-          </p:spPr>
-          <p:style>
-            <a:lnRef idx="1">
-              <a:schemeClr val="accent1"/>
-            </a:lnRef>
-            <a:fillRef idx="3">
-              <a:schemeClr val="accent1"/>
-            </a:fillRef>
-            <a:effectRef idx="2">
-              <a:schemeClr val="accent1"/>
-            </a:effectRef>
-            <a:fontRef idx="minor">
-              <a:schemeClr val="lt1"/>
-            </a:fontRef>
-          </p:style>
-          <p:txBody>
-            <a:bodyPr rtlCol="0" anchor="ctr"/>
-            <a:lstStyle/>
-            <a:p>
-              <a:pPr algn="ctr"/>
-            </a:p>
-          </p:txBody>
-        </p:sp>
-        <p:sp>
-          <p:nvSpPr>
-            <p:cNvPr id="29" name="Oval 28"/>
-            <p:cNvSpPr/>
-            <p:nvPr/>
-          </p:nvSpPr>
-          <p:spPr>
-            <a:xfrm>
-              <a:off x="10353675" y="4416742"/>
-              <a:ext cx="53340" cy="53340"/>
-            </a:xfrm>
-            <a:prstGeom prst="ellipse">
-              <a:avLst/>
-            </a:prstGeom>
-            <a:solidFill>
-              <a:srgbClr val="DBE6A7"/>
-            </a:solidFill>
-            <a:ln>
-              <a:noFill/>
-            </a:ln>
-            <a:effectLst/>
-          </p:spPr>
-          <p:style>
-            <a:lnRef idx="1">
-              <a:schemeClr val="accent1"/>
-            </a:lnRef>
-            <a:fillRef idx="3">
-              <a:schemeClr val="accent1"/>
-            </a:fillRef>
-            <a:effectRef idx="2">
-              <a:schemeClr val="accent1"/>
-            </a:effectRef>
-            <a:fontRef idx="minor">
-              <a:schemeClr val="lt1"/>
-            </a:fontRef>
-          </p:style>
-          <p:txBody>
-            <a:bodyPr rtlCol="0" anchor="ctr"/>
-            <a:lstStyle/>
-            <a:p>
-              <a:pPr algn="ctr"/>
-            </a:p>
-          </p:txBody>
-        </p:sp>
-        <p:sp>
-          <p:nvSpPr>
-            <p:cNvPr id="30" name="Oval 29"/>
-            <p:cNvSpPr/>
-            <p:nvPr/>
-          </p:nvSpPr>
-          <p:spPr>
-            <a:xfrm>
-              <a:off x="10180320" y="4550092"/>
-              <a:ext cx="53340" cy="53340"/>
-            </a:xfrm>
-            <a:prstGeom prst="ellipse">
-              <a:avLst/>
-            </a:prstGeom>
-            <a:solidFill>
-              <a:srgbClr val="DBE6A7"/>
-            </a:solidFill>
-            <a:ln>
-              <a:noFill/>
-            </a:ln>
-            <a:effectLst/>
-          </p:spPr>
-          <p:style>
-            <a:lnRef idx="1">
-              <a:schemeClr val="accent1"/>
-            </a:lnRef>
-            <a:fillRef idx="3">
-              <a:schemeClr val="accent1"/>
-            </a:fillRef>
-            <a:effectRef idx="2">
-              <a:schemeClr val="accent1"/>
-            </a:effectRef>
-            <a:fontRef idx="minor">
-              <a:schemeClr val="lt1"/>
-            </a:fontRef>
-          </p:style>
-          <p:txBody>
-            <a:bodyPr rtlCol="0" anchor="ctr"/>
-            <a:lstStyle/>
-            <a:p>
-              <a:pPr algn="ctr"/>
-            </a:p>
-          </p:txBody>
-        </p:sp>
-        <p:sp>
-          <p:nvSpPr>
-            <p:cNvPr id="31" name="Oval 30"/>
-            <p:cNvSpPr/>
-            <p:nvPr/>
-          </p:nvSpPr>
-          <p:spPr>
-            <a:xfrm>
-              <a:off x="10340340" y="4596765"/>
-              <a:ext cx="53340" cy="53340"/>
-            </a:xfrm>
-            <a:prstGeom prst="ellipse">
-              <a:avLst/>
-            </a:prstGeom>
-            <a:solidFill>
-              <a:srgbClr val="DBE6A7"/>
-            </a:solidFill>
-            <a:ln>
-              <a:noFill/>
-            </a:ln>
-            <a:effectLst/>
-          </p:spPr>
-          <p:style>
-            <a:lnRef idx="1">
-              <a:schemeClr val="accent1"/>
-            </a:lnRef>
-            <a:fillRef idx="3">
-              <a:schemeClr val="accent1"/>
-            </a:fillRef>
-            <a:effectRef idx="2">
-              <a:schemeClr val="accent1"/>
-            </a:effectRef>
-            <a:fontRef idx="minor">
-              <a:schemeClr val="lt1"/>
-            </a:fontRef>
-          </p:style>
-          <p:txBody>
-            <a:bodyPr rtlCol="0" anchor="ctr"/>
-            <a:lstStyle/>
-            <a:p>
-              <a:pPr algn="ctr"/>
-            </a:p>
-          </p:txBody>
-        </p:sp>
-      </p:grpSp>
-      <p:sp>
-        <p:nvSpPr>
-          <p:cNvPr id="32" name="TextBox 31"/>
+      <p:sp>
+        <p:nvSpPr>
+          <p:cNvPr id="18" name="TextBox 17"/>
           <p:cNvSpPr txBox="1"/>
           <p:nvPr/>
         </p:nvSpPr>
         <p:spPr>
           <a:xfrm>
-            <a:off x="476250" y="1428750"/>
+            <a:off x="571500" y="1390496"/>
             <a:ext cx="4953000" cy="2143454"/>
           </a:xfrm>
           <a:prstGeom prst="rect">
@@ -4768,21 +4171,37 @@
                 </a:solidFill>
                 <a:latin typeface="Montserrat"/>
               </a:rPr>
-              <a:t>39% more soil carbon</a:t>
-            </a:r>
-          </a:p>
-        </p:txBody>
-      </p:sp>
-      <p:sp>
-        <p:nvSpPr>
-          <p:cNvPr id="33" name="TextBox 32"/>
+              <a:t>39% more</a:t>
+            </a:r>
+          </a:p>
+          <a:p>
+            <a:pPr algn="l">
+              <a:lnSpc>
+                <a:spcPct val="105000"/>
+              </a:lnSpc>
+            </a:pPr>
+            <a:r>
+              <a:rPr sz="6400" b="1" i="0">
+                <a:solidFill>
+                  <a:srgbClr val="F4F1EA"/>
+                </a:solidFill>
+                <a:latin typeface="Montserrat"/>
+              </a:rPr>
+              <a:t>soil carbon</a:t>
+            </a:r>
+          </a:p>
+        </p:txBody>
+      </p:sp>
+      <p:sp>
+        <p:nvSpPr>
+          <p:cNvPr id="19" name="TextBox 18"/>
           <p:cNvSpPr txBox="1"/>
           <p:nvPr/>
         </p:nvSpPr>
         <p:spPr>
           <a:xfrm>
-            <a:off x="476250" y="3667454"/>
-            <a:ext cx="4762500" cy="857250"/>
+            <a:off x="571500" y="3667301"/>
+            <a:ext cx="4953000" cy="1009627"/>
           </a:xfrm>
           <a:prstGeom prst="rect">
             <a:avLst/>
@@ -4797,7 +4216,7 @@
           <a:p>
             <a:pPr algn="l">
               <a:lnSpc>
-                <a:spcPct val="120000"/>
+                <a:spcPct val="125000"/>
               </a:lnSpc>
             </a:pPr>
             <a:r>
@@ -4807,14 +4226,30 @@
                 </a:solidFill>
                 <a:latin typeface="Source Sans 3"/>
               </a:rPr>
-              <a:t>on the most regenerative farms, 1000 Farms Initiative, 2026</a:t>
+              <a:t>on the most regenerative farms,</a:t>
+            </a:r>
+          </a:p>
+          <a:p>
+            <a:pPr algn="l">
+              <a:lnSpc>
+                <a:spcPct val="125000"/>
+              </a:lnSpc>
+            </a:pPr>
+            <a:r>
+              <a:rPr sz="2400" b="0" i="0">
+                <a:solidFill>
+                  <a:srgbClr val="DBE6A7"/>
+                </a:solidFill>
+                <a:latin typeface="Source Sans 3"/>
+              </a:rPr>
+              <a:t>1000 Farms Initiative, 2026</a:t>
             </a:r>
           </a:p>
         </p:txBody>
       </p:sp>
       <p:pic>
         <p:nvPicPr>
-          <p:cNvPr id="34" name="Picture 33" descr="foundation-logo-white.png"/>
+          <p:cNvPr id="20" name="Picture 19" descr="foundation-logo-white.png"/>
           <p:cNvPicPr>
             <a:picLocks noChangeAspect="1"/>
           </p:cNvPicPr>

</xml_diff>

<commit_message>
1000 Farms study: clean marketing style, no scrapbook. 3-slide seamless Instagram carousel and a new LinkedIn image
Co-Authored-By: Claude Opus 5.5 <noreply@anthropic.com>
Claude-Session: https://claude.ai/code/session_014HGzAbxBh54nuyJHG7tse8
</commit_message>
<xml_diff>
--- a/templates/posts/october/02-10-2026-fri-li-1000-farms-study.pptx
+++ b/templates/posts/october/02-10-2026-fri-li-1000-farms-study.pptx
@@ -502,7 +502,7 @@
           <a:lstStyle/>
           <a:p>
             <a:r>
-              <a:t>LinkedIn image. Sources: Lundgren et al., Environmental Research: Food Systems, 2026, https://doi.org/10.1088/2976-601X/ae8f4e; Ecdysis Foundation press release, 17 September 2026, https://www.globenewswire.com/news-release/2026/09/17/3363925/0/en/regenerative-farming-outpaces-tech-based-carbon-capture-solutions-in-first-large-scale-systemic-study.html Right half: the slide 1 field collage on a taped paper card (not tilted), on Food Web Green.</a:t>
+              <a:t>LinkedIn image. Sources: Lundgren et al., Environmental Research: Food Systems, 2026, https://doi.org/10.1088/2976-601X/ae8f4e; Ecdysis Foundation press release, 17 September 2026, https://www.globenewswire.com/news-release/2026/09/17/3363925/0/en/regenerative-farming-outpaces-tech-based-carbon-capture-solutions-in-first-large-scale-systemic-study.html Photo: assets/photo/handling-loose-soil.jpg (Foundation library, not a 1000 Farms site).</a:t>
             </a:r>
           </a:p>
         </p:txBody>
@@ -3516,22 +3516,46 @@
         <p:nvPr/>
       </p:nvGrpSpPr>
       <p:grpSpPr/>
-      <p:sp>
-        <p:nvSpPr>
-          <p:cNvPr id="2" name="Rectangle 1"/>
+      <p:pic>
+        <p:nvPicPr>
+          <p:cNvPr id="2" name="Picture 1" descr="8386617764061229935.jpg"/>
+          <p:cNvPicPr>
+            <a:picLocks noChangeAspect="1"/>
+          </p:cNvPicPr>
+          <p:nvPr/>
+        </p:nvPicPr>
+        <p:blipFill>
+          <a:blip r:embed="rId3"/>
+          <a:stretch>
+            <a:fillRect/>
+          </a:stretch>
+        </p:blipFill>
+        <p:spPr>
+          <a:xfrm>
+            <a:off x="6096000" y="0"/>
+            <a:ext cx="5334000" cy="5972175"/>
+          </a:xfrm>
+          <a:prstGeom prst="rect">
+            <a:avLst/>
+          </a:prstGeom>
+        </p:spPr>
+      </p:pic>
+      <p:sp>
+        <p:nvSpPr>
+          <p:cNvPr id="3" name="Rectangle 2"/>
           <p:cNvSpPr/>
           <p:nvPr/>
         </p:nvSpPr>
         <p:spPr>
           <a:xfrm>
-            <a:off x="5715000" y="0"/>
-            <a:ext cx="5715000" cy="5972175"/>
+            <a:off x="6096000" y="0"/>
+            <a:ext cx="57150" cy="5972175"/>
           </a:xfrm>
           <a:prstGeom prst="rect">
             <a:avLst/>
           </a:prstGeom>
           <a:solidFill>
-            <a:srgbClr val="156826"/>
+            <a:srgbClr val="DBE6A7"/>
           </a:solidFill>
           <a:ln>
             <a:noFill/>
@@ -3562,72 +3586,98 @@
       </p:sp>
       <p:sp>
         <p:nvSpPr>
-          <p:cNvPr id="3" name="Rectangle 2"/>
+          <p:cNvPr id="4" name="TextBox 3"/>
+          <p:cNvSpPr txBox="1"/>
+          <p:nvPr/>
+        </p:nvSpPr>
+        <p:spPr>
+          <a:xfrm>
+            <a:off x="609600" y="904875"/>
+            <a:ext cx="5334000" cy="1619250"/>
+          </a:xfrm>
+          <a:prstGeom prst="rect">
+            <a:avLst/>
+          </a:prstGeom>
+          <a:noFill/>
+        </p:spPr>
+        <p:txBody>
+          <a:bodyPr wrap="square" lIns="0" rIns="0" tIns="0" bIns="0" anchor="t">
+            <a:spAutoFit/>
+          </a:bodyPr>
+          <a:lstStyle/>
+          <a:p>
+            <a:pPr algn="l">
+              <a:lnSpc>
+                <a:spcPct val="100000"/>
+              </a:lnSpc>
+            </a:pPr>
+            <a:r>
+              <a:rPr sz="15000" b="1" i="0">
+                <a:solidFill>
+                  <a:srgbClr val="F4F1EA"/>
+                </a:solidFill>
+                <a:latin typeface="Montserrat"/>
+              </a:rPr>
+              <a:t>39%</a:t>
+            </a:r>
+          </a:p>
+        </p:txBody>
+      </p:sp>
+      <p:sp>
+        <p:nvSpPr>
+          <p:cNvPr id="5" name="TextBox 4"/>
+          <p:cNvSpPr txBox="1"/>
+          <p:nvPr/>
+        </p:nvSpPr>
+        <p:spPr>
+          <a:xfrm>
+            <a:off x="666750" y="2838450"/>
+            <a:ext cx="5334000" cy="533400"/>
+          </a:xfrm>
+          <a:prstGeom prst="rect">
+            <a:avLst/>
+          </a:prstGeom>
+          <a:noFill/>
+        </p:spPr>
+        <p:txBody>
+          <a:bodyPr wrap="square" lIns="0" rIns="0" tIns="0" bIns="0" anchor="t">
+            <a:spAutoFit/>
+          </a:bodyPr>
+          <a:lstStyle/>
+          <a:p>
+            <a:pPr algn="l">
+              <a:lnSpc>
+                <a:spcPct val="100000"/>
+              </a:lnSpc>
+            </a:pPr>
+            <a:r>
+              <a:rPr sz="4000" b="1" i="0">
+                <a:solidFill>
+                  <a:srgbClr val="F4F1EA"/>
+                </a:solidFill>
+                <a:latin typeface="Montserrat"/>
+              </a:rPr>
+              <a:t>more soil carbon</a:t>
+            </a:r>
+          </a:p>
+        </p:txBody>
+      </p:sp>
+      <p:sp>
+        <p:nvSpPr>
+          <p:cNvPr id="6" name="Rectangle 5"/>
           <p:cNvSpPr/>
           <p:nvPr/>
         </p:nvSpPr>
         <p:spPr>
           <a:xfrm>
-            <a:off x="6191250" y="571500"/>
-            <a:ext cx="4762500" cy="4095750"/>
+            <a:off x="685800" y="3619500"/>
+            <a:ext cx="762000" cy="38100"/>
           </a:xfrm>
           <a:prstGeom prst="rect">
             <a:avLst/>
           </a:prstGeom>
           <a:solidFill>
-            <a:srgbClr val="FFFDF7"/>
-          </a:solidFill>
-          <a:ln>
-            <a:noFill/>
-          </a:ln>
-          <a:effectLst>
-            <a:outerShdw blurRad="228600" dist="76200" dir="5400000" algn="t" rotWithShape="0">
-              <a:srgbClr val="000000">
-                <a:alpha val="30000"/>
-              </a:srgbClr>
-            </a:outerShdw>
-          </a:effectLst>
-        </p:spPr>
-        <p:style>
-          <a:lnRef idx="1">
-            <a:schemeClr val="accent1"/>
-          </a:lnRef>
-          <a:fillRef idx="3">
-            <a:schemeClr val="accent1"/>
-          </a:fillRef>
-          <a:effectRef idx="2">
-            <a:schemeClr val="accent1"/>
-          </a:effectRef>
-          <a:fontRef idx="minor">
-            <a:schemeClr val="lt1"/>
-          </a:fontRef>
-        </p:style>
-        <p:txBody>
-          <a:bodyPr rtlCol="0" anchor="ctr"/>
-          <a:lstStyle/>
-          <a:p>
-            <a:pPr algn="ctr"/>
-          </a:p>
-        </p:txBody>
-      </p:sp>
-      <p:sp>
-        <p:nvSpPr>
-          <p:cNvPr id="4" name="Rectangle 3"/>
-          <p:cNvSpPr/>
-          <p:nvPr/>
-        </p:nvSpPr>
-        <p:spPr>
-          <a:xfrm rot="19920000">
-            <a:off x="6048375" y="419100"/>
-            <a:ext cx="1428750" cy="419100"/>
-          </a:xfrm>
-          <a:prstGeom prst="rect">
-            <a:avLst/>
-          </a:prstGeom>
-          <a:solidFill>
-            <a:srgbClr val="DBE6A7">
-              <a:alpha val="70000"/>
-            </a:srgbClr>
+            <a:srgbClr val="DBE6A7"/>
           </a:solidFill>
           <a:ln>
             <a:noFill/>
@@ -3658,77 +3708,101 @@
       </p:sp>
       <p:sp>
         <p:nvSpPr>
-          <p:cNvPr id="5" name="Rectangle 4"/>
-          <p:cNvSpPr/>
+          <p:cNvPr id="7" name="TextBox 6"/>
+          <p:cNvSpPr txBox="1"/>
           <p:nvPr/>
         </p:nvSpPr>
         <p:spPr>
-          <a:xfrm rot="1680000">
-            <a:off x="9667875" y="419100"/>
-            <a:ext cx="1428750" cy="419100"/>
+          <a:xfrm>
+            <a:off x="666750" y="3829050"/>
+            <a:ext cx="5143500" cy="762000"/>
           </a:xfrm>
           <a:prstGeom prst="rect">
             <a:avLst/>
           </a:prstGeom>
-          <a:solidFill>
-            <a:srgbClr val="DBE6A7">
-              <a:alpha val="70000"/>
-            </a:srgbClr>
-          </a:solidFill>
-          <a:ln>
-            <a:noFill/>
-          </a:ln>
-          <a:effectLst/>
+          <a:noFill/>
         </p:spPr>
-        <p:style>
-          <a:lnRef idx="1">
-            <a:schemeClr val="accent1"/>
-          </a:lnRef>
-          <a:fillRef idx="3">
-            <a:schemeClr val="accent1"/>
-          </a:fillRef>
-          <a:effectRef idx="2">
-            <a:schemeClr val="accent1"/>
-          </a:effectRef>
-          <a:fontRef idx="minor">
-            <a:schemeClr val="lt1"/>
-          </a:fontRef>
-        </p:style>
-        <p:txBody>
-          <a:bodyPr rtlCol="0" anchor="ctr"/>
-          <a:lstStyle/>
-          <a:p>
-            <a:pPr algn="ctr"/>
-          </a:p>
-        </p:txBody>
-      </p:sp>
-      <p:pic>
-        <p:nvPicPr>
-          <p:cNvPr id="6" name="Picture 5" descr="trim-cut-brown-brush.png"/>
-          <p:cNvPicPr>
-            <a:picLocks noChangeAspect="1"/>
-          </p:cNvPicPr>
+        <p:txBody>
+          <a:bodyPr wrap="square" lIns="0" rIns="0" tIns="0" bIns="0" anchor="t">
+            <a:spAutoFit/>
+          </a:bodyPr>
+          <a:lstStyle/>
+          <a:p>
+            <a:pPr algn="l">
+              <a:lnSpc>
+                <a:spcPct val="125000"/>
+              </a:lnSpc>
+            </a:pPr>
+            <a:r>
+              <a:rPr sz="2400" b="0" i="0">
+                <a:solidFill>
+                  <a:srgbClr val="DBE6A7"/>
+                </a:solidFill>
+                <a:latin typeface="Source Sans 3"/>
+              </a:rPr>
+              <a:t>on the most regenerative farms,</a:t>
+            </a:r>
+          </a:p>
+          <a:p>
+            <a:pPr algn="l">
+              <a:lnSpc>
+                <a:spcPct val="125000"/>
+              </a:lnSpc>
+            </a:pPr>
+            <a:r>
+              <a:rPr sz="2400" b="0" i="0">
+                <a:solidFill>
+                  <a:srgbClr val="DBE6A7"/>
+                </a:solidFill>
+                <a:latin typeface="Source Sans 3"/>
+              </a:rPr>
+              <a:t>1000 Farms Initiative, 2026</a:t>
+            </a:r>
+          </a:p>
+        </p:txBody>
+      </p:sp>
+      <p:sp>
+        <p:nvSpPr>
+          <p:cNvPr id="8" name="TextBox 7"/>
+          <p:cNvSpPr txBox="1"/>
           <p:nvPr/>
-        </p:nvPicPr>
-        <p:blipFill>
-          <a:blip r:embed="rId3"/>
-          <a:stretch>
-            <a:fillRect/>
-          </a:stretch>
-        </p:blipFill>
+        </p:nvSpPr>
         <p:spPr>
           <a:xfrm>
-            <a:off x="6557010" y="2247900"/>
-            <a:ext cx="4030980" cy="2080260"/>
+            <a:off x="666750" y="5334000"/>
+            <a:ext cx="5143500" cy="285750"/>
           </a:xfrm>
           <a:prstGeom prst="rect">
             <a:avLst/>
           </a:prstGeom>
+          <a:noFill/>
         </p:spPr>
-      </p:pic>
+        <p:txBody>
+          <a:bodyPr wrap="square" lIns="0" rIns="0" tIns="0" bIns="0" anchor="t">
+            <a:spAutoFit/>
+          </a:bodyPr>
+          <a:lstStyle/>
+          <a:p>
+            <a:pPr algn="l">
+              <a:lnSpc>
+                <a:spcPct val="120000"/>
+              </a:lnSpc>
+            </a:pPr>
+            <a:r>
+              <a:rPr sz="1600" b="0" i="0">
+                <a:solidFill>
+                  <a:srgbClr val="F4F1EA"/>
+                </a:solidFill>
+                <a:latin typeface="Source Sans 3"/>
+              </a:rPr>
+              <a:t>Lundgren et al. 2026, Environ. Res.: Food Syst.</a:t>
+            </a:r>
+          </a:p>
+        </p:txBody>
+      </p:sp>
       <p:pic>
         <p:nvPicPr>
-          <p:cNvPr id="7" name="Picture 6" descr="trim-fern-green.png"/>
+          <p:cNvPr id="9" name="Picture 8" descr="foundation-logo-white.png"/>
           <p:cNvPicPr>
             <a:picLocks noChangeAspect="1"/>
           </p:cNvPicPr>
@@ -3736,527 +3810,6 @@
         </p:nvPicPr>
         <p:blipFill>
           <a:blip r:embed="rId4"/>
-          <a:stretch>
-            <a:fillRect/>
-          </a:stretch>
-        </p:blipFill>
-        <p:spPr>
-          <a:xfrm rot="21120000">
-            <a:off x="6688455" y="1319261"/>
-            <a:ext cx="2190750" cy="1114326"/>
-          </a:xfrm>
-          <a:prstGeom prst="rect">
-            <a:avLst/>
-          </a:prstGeom>
-        </p:spPr>
-      </p:pic>
-      <p:pic>
-        <p:nvPicPr>
-          <p:cNvPr id="8" name="Picture 7" descr="trim-fern-sage.png"/>
-          <p:cNvPicPr>
-            <a:picLocks noChangeAspect="1"/>
-          </p:cNvPicPr>
-          <p:nvPr/>
-        </p:nvPicPr>
-        <p:blipFill>
-          <a:blip r:embed="rId5"/>
-          <a:stretch>
-            <a:fillRect/>
-          </a:stretch>
-        </p:blipFill>
-        <p:spPr>
-          <a:xfrm rot="11400000">
-            <a:off x="8462962" y="1372581"/>
-            <a:ext cx="1971675" cy="1007687"/>
-          </a:xfrm>
-          <a:prstGeom prst="rect">
-            <a:avLst/>
-          </a:prstGeom>
-        </p:spPr>
-      </p:pic>
-      <p:pic>
-        <p:nvPicPr>
-          <p:cNvPr id="9" name="Picture 8" descr="trim-fungal-hyphae-1.png"/>
-          <p:cNvPicPr>
-            <a:picLocks noChangeAspect="1"/>
-          </p:cNvPicPr>
-          <p:nvPr/>
-        </p:nvPicPr>
-        <p:blipFill>
-          <a:blip r:embed="rId6"/>
-          <a:stretch>
-            <a:fillRect/>
-          </a:stretch>
-        </p:blipFill>
-        <p:spPr>
-          <a:xfrm rot="5400000">
-            <a:off x="7367587" y="2001855"/>
-            <a:ext cx="2409825" cy="2572348"/>
-          </a:xfrm>
-          <a:prstGeom prst="rect">
-            <a:avLst/>
-          </a:prstGeom>
-        </p:spPr>
-      </p:pic>
-      <p:grpSp>
-        <p:nvGrpSpPr>
-          <p:cNvPr id="10" name="Group 9"/>
-          <p:cNvGrpSpPr/>
-          <p:nvPr/>
-        </p:nvGrpSpPr>
-        <p:grpSpPr>
-          <a:xfrm rot="21240000">
-            <a:off x="0" y="0"/>
-            <a:ext cx="7096125" cy="5638800"/>
-            <a:chOff x="0" y="0"/>
-            <a:chExt cx="7096125" cy="5638800"/>
-          </a:xfrm>
-        </p:grpSpPr>
-        <p:sp>
-          <p:nvSpPr>
-            <p:cNvPr id="11" name="Rectangle 10"/>
-            <p:cNvSpPr/>
-            <p:nvPr/>
-          </p:nvSpPr>
-          <p:spPr>
-            <a:xfrm>
-              <a:off x="6534150" y="4779645"/>
-              <a:ext cx="76200" cy="649605"/>
-            </a:xfrm>
-            <a:prstGeom prst="rect">
-              <a:avLst/>
-            </a:prstGeom>
-            <a:solidFill>
-              <a:srgbClr val="7FA05A"/>
-            </a:solidFill>
-            <a:ln>
-              <a:noFill/>
-            </a:ln>
-            <a:effectLst/>
-          </p:spPr>
-          <p:style>
-            <a:lnRef idx="1">
-              <a:schemeClr val="accent1"/>
-            </a:lnRef>
-            <a:fillRef idx="3">
-              <a:schemeClr val="accent1"/>
-            </a:fillRef>
-            <a:effectRef idx="2">
-              <a:schemeClr val="accent1"/>
-            </a:effectRef>
-            <a:fontRef idx="minor">
-              <a:schemeClr val="lt1"/>
-            </a:fontRef>
-          </p:style>
-          <p:txBody>
-            <a:bodyPr rtlCol="0" anchor="ctr"/>
-            <a:lstStyle/>
-            <a:p>
-              <a:pPr algn="ctr"/>
-            </a:p>
-          </p:txBody>
-        </p:sp>
-        <p:sp>
-          <p:nvSpPr>
-            <p:cNvPr id="12" name="Oval 11"/>
-            <p:cNvSpPr/>
-            <p:nvPr/>
-          </p:nvSpPr>
-          <p:spPr>
-            <a:xfrm rot="8700000">
-              <a:off x="6153150" y="4632960"/>
-              <a:ext cx="419100" cy="209550"/>
-            </a:xfrm>
-            <a:prstGeom prst="ellipse">
-              <a:avLst/>
-            </a:prstGeom>
-            <a:solidFill>
-              <a:srgbClr val="59A66C"/>
-            </a:solidFill>
-            <a:ln w="57150">
-              <a:solidFill>
-                <a:srgbClr val="FFFFFF"/>
-              </a:solidFill>
-            </a:ln>
-            <a:effectLst/>
-          </p:spPr>
-          <p:style>
-            <a:lnRef idx="1">
-              <a:schemeClr val="accent1"/>
-            </a:lnRef>
-            <a:fillRef idx="3">
-              <a:schemeClr val="accent1"/>
-            </a:fillRef>
-            <a:effectRef idx="2">
-              <a:schemeClr val="accent1"/>
-            </a:effectRef>
-            <a:fontRef idx="minor">
-              <a:schemeClr val="lt1"/>
-            </a:fontRef>
-          </p:style>
-          <p:txBody>
-            <a:bodyPr rtlCol="0" anchor="ctr"/>
-            <a:lstStyle/>
-            <a:p>
-              <a:pPr algn="ctr"/>
-            </a:p>
-          </p:txBody>
-        </p:sp>
-        <p:sp>
-          <p:nvSpPr>
-            <p:cNvPr id="13" name="Oval 12"/>
-            <p:cNvSpPr/>
-            <p:nvPr/>
-          </p:nvSpPr>
-          <p:spPr>
-            <a:xfrm rot="2100000">
-              <a:off x="6572250" y="4632960"/>
-              <a:ext cx="419100" cy="209550"/>
-            </a:xfrm>
-            <a:prstGeom prst="ellipse">
-              <a:avLst/>
-            </a:prstGeom>
-            <a:solidFill>
-              <a:srgbClr val="59A66C"/>
-            </a:solidFill>
-            <a:ln w="57150">
-              <a:solidFill>
-                <a:srgbClr val="FFFFFF"/>
-              </a:solidFill>
-            </a:ln>
-            <a:effectLst/>
-          </p:spPr>
-          <p:style>
-            <a:lnRef idx="1">
-              <a:schemeClr val="accent1"/>
-            </a:lnRef>
-            <a:fillRef idx="3">
-              <a:schemeClr val="accent1"/>
-            </a:fillRef>
-            <a:effectRef idx="2">
-              <a:schemeClr val="accent1"/>
-            </a:effectRef>
-            <a:fontRef idx="minor">
-              <a:schemeClr val="lt1"/>
-            </a:fontRef>
-          </p:style>
-          <p:txBody>
-            <a:bodyPr rtlCol="0" anchor="ctr"/>
-            <a:lstStyle/>
-            <a:p>
-              <a:pPr algn="ctr"/>
-            </a:p>
-          </p:txBody>
-        </p:sp>
-        <p:sp>
-          <p:nvSpPr>
-            <p:cNvPr id="14" name="Oval 13"/>
-            <p:cNvSpPr/>
-            <p:nvPr/>
-          </p:nvSpPr>
-          <p:spPr>
-            <a:xfrm>
-              <a:off x="6048375" y="5324475"/>
-              <a:ext cx="1047750" cy="314325"/>
-            </a:xfrm>
-            <a:prstGeom prst="ellipse">
-              <a:avLst/>
-            </a:prstGeom>
-            <a:solidFill>
-              <a:srgbClr val="4F3433"/>
-            </a:solidFill>
-            <a:ln w="57150">
-              <a:solidFill>
-                <a:srgbClr val="FFFFFF"/>
-              </a:solidFill>
-            </a:ln>
-            <a:effectLst>
-              <a:outerShdw blurRad="228600" dist="76200" dir="5400000" algn="t" rotWithShape="0">
-                <a:srgbClr val="000000">
-                  <a:alpha val="30000"/>
-                </a:srgbClr>
-              </a:outerShdw>
-            </a:effectLst>
-          </p:spPr>
-          <p:style>
-            <a:lnRef idx="1">
-              <a:schemeClr val="accent1"/>
-            </a:lnRef>
-            <a:fillRef idx="3">
-              <a:schemeClr val="accent1"/>
-            </a:fillRef>
-            <a:effectRef idx="2">
-              <a:schemeClr val="accent1"/>
-            </a:effectRef>
-            <a:fontRef idx="minor">
-              <a:schemeClr val="lt1"/>
-            </a:fontRef>
-          </p:style>
-          <p:txBody>
-            <a:bodyPr rtlCol="0" anchor="ctr"/>
-            <a:lstStyle/>
-            <a:p>
-              <a:pPr algn="ctr"/>
-            </a:p>
-          </p:txBody>
-        </p:sp>
-        <p:sp>
-          <p:nvSpPr>
-            <p:cNvPr id="15" name="Oval 14"/>
-            <p:cNvSpPr/>
-            <p:nvPr/>
-          </p:nvSpPr>
-          <p:spPr>
-            <a:xfrm>
-              <a:off x="6493668" y="5446578"/>
-              <a:ext cx="28208" cy="28208"/>
-            </a:xfrm>
-            <a:prstGeom prst="ellipse">
-              <a:avLst/>
-            </a:prstGeom>
-            <a:solidFill>
-              <a:srgbClr val="F4F1EA"/>
-            </a:solidFill>
-            <a:ln>
-              <a:noFill/>
-            </a:ln>
-            <a:effectLst/>
-          </p:spPr>
-          <p:style>
-            <a:lnRef idx="1">
-              <a:schemeClr val="accent1"/>
-            </a:lnRef>
-            <a:fillRef idx="3">
-              <a:schemeClr val="accent1"/>
-            </a:fillRef>
-            <a:effectRef idx="2">
-              <a:schemeClr val="accent1"/>
-            </a:effectRef>
-            <a:fontRef idx="minor">
-              <a:schemeClr val="lt1"/>
-            </a:fontRef>
-          </p:style>
-          <p:txBody>
-            <a:bodyPr rtlCol="0" anchor="ctr"/>
-            <a:lstStyle/>
-            <a:p>
-              <a:pPr algn="ctr"/>
-            </a:p>
-          </p:txBody>
-        </p:sp>
-        <p:sp>
-          <p:nvSpPr>
-            <p:cNvPr id="16" name="Oval 15"/>
-            <p:cNvSpPr/>
-            <p:nvPr/>
-          </p:nvSpPr>
-          <p:spPr>
-            <a:xfrm>
-              <a:off x="6622622" y="5446578"/>
-              <a:ext cx="28208" cy="28208"/>
-            </a:xfrm>
-            <a:prstGeom prst="ellipse">
-              <a:avLst/>
-            </a:prstGeom>
-            <a:solidFill>
-              <a:srgbClr val="F4F1EA"/>
-            </a:solidFill>
-            <a:ln>
-              <a:noFill/>
-            </a:ln>
-            <a:effectLst/>
-          </p:spPr>
-          <p:style>
-            <a:lnRef idx="1">
-              <a:schemeClr val="accent1"/>
-            </a:lnRef>
-            <a:fillRef idx="3">
-              <a:schemeClr val="accent1"/>
-            </a:fillRef>
-            <a:effectRef idx="2">
-              <a:schemeClr val="accent1"/>
-            </a:effectRef>
-            <a:fontRef idx="minor">
-              <a:schemeClr val="lt1"/>
-            </a:fontRef>
-          </p:style>
-          <p:txBody>
-            <a:bodyPr rtlCol="0" anchor="ctr"/>
-            <a:lstStyle/>
-            <a:p>
-              <a:pPr algn="ctr"/>
-            </a:p>
-          </p:txBody>
-        </p:sp>
-        <p:sp>
-          <p:nvSpPr>
-            <p:cNvPr id="17" name="Block Arc 16"/>
-            <p:cNvSpPr/>
-            <p:nvPr/>
-          </p:nvSpPr>
-          <p:spPr>
-            <a:xfrm rot="10800000">
-              <a:off x="6527922" y="5468742"/>
-              <a:ext cx="88655" cy="64476"/>
-            </a:xfrm>
-            <a:prstGeom prst="blockArc">
-              <a:avLst>
-                <a:gd name="adj1" fmla="val 10800000"/>
-                <a:gd name="adj2" fmla="val 0"/>
-                <a:gd name="adj3" fmla="val 18000"/>
-              </a:avLst>
-            </a:prstGeom>
-            <a:solidFill>
-              <a:srgbClr val="F4F1EA"/>
-            </a:solidFill>
-            <a:ln>
-              <a:noFill/>
-            </a:ln>
-            <a:effectLst/>
-          </p:spPr>
-          <p:style>
-            <a:lnRef idx="1">
-              <a:schemeClr val="accent1"/>
-            </a:lnRef>
-            <a:fillRef idx="3">
-              <a:schemeClr val="accent1"/>
-            </a:fillRef>
-            <a:effectRef idx="2">
-              <a:schemeClr val="accent1"/>
-            </a:effectRef>
-            <a:fontRef idx="minor">
-              <a:schemeClr val="lt1"/>
-            </a:fontRef>
-          </p:style>
-          <p:txBody>
-            <a:bodyPr rtlCol="0" anchor="ctr"/>
-            <a:lstStyle/>
-            <a:p>
-              <a:pPr algn="ctr"/>
-            </a:p>
-          </p:txBody>
-        </p:sp>
-      </p:grpSp>
-      <p:sp>
-        <p:nvSpPr>
-          <p:cNvPr id="18" name="TextBox 17"/>
-          <p:cNvSpPr txBox="1"/>
-          <p:nvPr/>
-        </p:nvSpPr>
-        <p:spPr>
-          <a:xfrm>
-            <a:off x="571500" y="1390496"/>
-            <a:ext cx="4953000" cy="2143454"/>
-          </a:xfrm>
-          <a:prstGeom prst="rect">
-            <a:avLst/>
-          </a:prstGeom>
-          <a:noFill/>
-        </p:spPr>
-        <p:txBody>
-          <a:bodyPr wrap="square" lIns="0" rIns="0" tIns="0" bIns="0" anchor="t">
-            <a:spAutoFit/>
-          </a:bodyPr>
-          <a:lstStyle/>
-          <a:p>
-            <a:pPr algn="l">
-              <a:lnSpc>
-                <a:spcPct val="105000"/>
-              </a:lnSpc>
-            </a:pPr>
-            <a:r>
-              <a:rPr sz="6400" b="1" i="0">
-                <a:solidFill>
-                  <a:srgbClr val="F4F1EA"/>
-                </a:solidFill>
-                <a:latin typeface="Montserrat"/>
-              </a:rPr>
-              <a:t>39% more</a:t>
-            </a:r>
-          </a:p>
-          <a:p>
-            <a:pPr algn="l">
-              <a:lnSpc>
-                <a:spcPct val="105000"/>
-              </a:lnSpc>
-            </a:pPr>
-            <a:r>
-              <a:rPr sz="6400" b="1" i="0">
-                <a:solidFill>
-                  <a:srgbClr val="F4F1EA"/>
-                </a:solidFill>
-                <a:latin typeface="Montserrat"/>
-              </a:rPr>
-              <a:t>soil carbon</a:t>
-            </a:r>
-          </a:p>
-        </p:txBody>
-      </p:sp>
-      <p:sp>
-        <p:nvSpPr>
-          <p:cNvPr id="19" name="TextBox 18"/>
-          <p:cNvSpPr txBox="1"/>
-          <p:nvPr/>
-        </p:nvSpPr>
-        <p:spPr>
-          <a:xfrm>
-            <a:off x="571500" y="3667301"/>
-            <a:ext cx="4953000" cy="1009627"/>
-          </a:xfrm>
-          <a:prstGeom prst="rect">
-            <a:avLst/>
-          </a:prstGeom>
-          <a:noFill/>
-        </p:spPr>
-        <p:txBody>
-          <a:bodyPr wrap="square" lIns="0" rIns="0" tIns="0" bIns="0" anchor="t">
-            <a:spAutoFit/>
-          </a:bodyPr>
-          <a:lstStyle/>
-          <a:p>
-            <a:pPr algn="l">
-              <a:lnSpc>
-                <a:spcPct val="125000"/>
-              </a:lnSpc>
-            </a:pPr>
-            <a:r>
-              <a:rPr sz="2400" b="0" i="0">
-                <a:solidFill>
-                  <a:srgbClr val="DBE6A7"/>
-                </a:solidFill>
-                <a:latin typeface="Source Sans 3"/>
-              </a:rPr>
-              <a:t>on the most regenerative farms,</a:t>
-            </a:r>
-          </a:p>
-          <a:p>
-            <a:pPr algn="l">
-              <a:lnSpc>
-                <a:spcPct val="125000"/>
-              </a:lnSpc>
-            </a:pPr>
-            <a:r>
-              <a:rPr sz="2400" b="0" i="0">
-                <a:solidFill>
-                  <a:srgbClr val="DBE6A7"/>
-                </a:solidFill>
-                <a:latin typeface="Source Sans 3"/>
-              </a:rPr>
-              <a:t>1000 Farms Initiative, 2026</a:t>
-            </a:r>
-          </a:p>
-        </p:txBody>
-      </p:sp>
-      <p:pic>
-        <p:nvPicPr>
-          <p:cNvPr id="20" name="Picture 19" descr="foundation-logo-white.png"/>
-          <p:cNvPicPr>
-            <a:picLocks noChangeAspect="1"/>
-          </p:cNvPicPr>
-          <p:nvPr/>
-        </p:nvPicPr>
-        <p:blipFill>
-          <a:blip r:embed="rId7"/>
           <a:stretch>
             <a:fillRect/>
           </a:stretch>

</xml_diff>